<commit_message>
Added new metrics for total ticks
</commit_message>
<xml_diff>
--- a/docs/elevator_strategies_summary.pptx
+++ b/docs/elevator_strategies_summary.pptx
@@ -7482,11 +7482,17 @@
           <p:cNvGraphicFramePr>
             <a:graphicFrameLocks noGrp="1"/>
           </p:cNvGraphicFramePr>
-          <p:nvPr/>
+          <p:nvPr>
+            <p:extLst>
+              <p:ext uri="{D42A27DB-BD31-4B8C-83A1-F6EECF244321}">
+                <p14:modId xmlns:p14="http://schemas.microsoft.com/office/powerpoint/2010/main" val="1989648565"/>
+              </p:ext>
+            </p:extLst>
+          </p:nvPr>
         </p:nvGraphicFramePr>
         <p:xfrm>
           <a:off x="457200" y="1737360"/>
-          <a:ext cx="11795760" cy="3688080"/>
+          <a:ext cx="11340193" cy="4145280"/>
         </p:xfrm>
         <a:graphic>
           <a:graphicData uri="http://schemas.openxmlformats.org/drawingml/2006/table">
@@ -7495,49 +7501,49 @@
                 <a:tableStyleId>{5C22544A-7EE6-4342-B048-85BDC9FD1C3A}</a:tableStyleId>
               </a:tblPr>
               <a:tblGrid>
-                <a:gridCol w="2468880">
+                <a:gridCol w="2318657">
                   <a:extLst>
                     <a:ext uri="{9D8B030D-6E8A-4147-A177-3AD203B41FA5}">
                       <a16:colId xmlns:a16="http://schemas.microsoft.com/office/drawing/2014/main" val="20000"/>
                     </a:ext>
                   </a:extLst>
                 </a:gridCol>
-                <a:gridCol w="1554480">
+                <a:gridCol w="1549316">
                   <a:extLst>
                     <a:ext uri="{9D8B030D-6E8A-4147-A177-3AD203B41FA5}">
                       <a16:colId xmlns:a16="http://schemas.microsoft.com/office/drawing/2014/main" val="20001"/>
                     </a:ext>
                   </a:extLst>
                 </a:gridCol>
-                <a:gridCol w="1554480">
+                <a:gridCol w="1494444">
                   <a:extLst>
                     <a:ext uri="{9D8B030D-6E8A-4147-A177-3AD203B41FA5}">
                       <a16:colId xmlns:a16="http://schemas.microsoft.com/office/drawing/2014/main" val="20002"/>
                     </a:ext>
                   </a:extLst>
                 </a:gridCol>
-                <a:gridCol w="1554480">
+                <a:gridCol w="1494444">
                   <a:extLst>
                     <a:ext uri="{9D8B030D-6E8A-4147-A177-3AD203B41FA5}">
                       <a16:colId xmlns:a16="http://schemas.microsoft.com/office/drawing/2014/main" val="20003"/>
                     </a:ext>
                   </a:extLst>
                 </a:gridCol>
-                <a:gridCol w="1554480">
+                <a:gridCol w="1494444">
                   <a:extLst>
                     <a:ext uri="{9D8B030D-6E8A-4147-A177-3AD203B41FA5}">
                       <a16:colId xmlns:a16="http://schemas.microsoft.com/office/drawing/2014/main" val="20004"/>
                     </a:ext>
                   </a:extLst>
                 </a:gridCol>
-                <a:gridCol w="1554480">
+                <a:gridCol w="1494444">
                   <a:extLst>
                     <a:ext uri="{9D8B030D-6E8A-4147-A177-3AD203B41FA5}">
                       <a16:colId xmlns:a16="http://schemas.microsoft.com/office/drawing/2014/main" val="20005"/>
                     </a:ext>
                   </a:extLst>
                 </a:gridCol>
-                <a:gridCol w="1554480">
+                <a:gridCol w="1494444">
                   <a:extLst>
                     <a:ext uri="{9D8B030D-6E8A-4147-A177-3AD203B41FA5}">
                       <a16:colId xmlns:a16="http://schemas.microsoft.com/office/drawing/2014/main" val="20006"/>
@@ -7584,6 +7590,7 @@
                         </a:defRPr>
                       </a:pPr>
                       <a:r>
+                        <a:rPr dirty="0"/>
                         <a:t>ROUND_ROBIN</a:t>
                       </a:r>
                     </a:p>
@@ -8833,6 +8840,7 @@
                         </a:defRPr>
                       </a:pPr>
                       <a:r>
+                        <a:rPr dirty="0"/>
                         <a:t>0.894</a:t>
                       </a:r>
                     </a:p>
@@ -8857,6 +8865,7 @@
                         </a:defRPr>
                       </a:pPr>
                       <a:r>
+                        <a:rPr dirty="0"/>
                         <a:t>0.980</a:t>
                       </a:r>
                     </a:p>
@@ -8881,6 +8890,7 @@
                         </a:defRPr>
                       </a:pPr>
                       <a:r>
+                        <a:rPr dirty="0"/>
                         <a:t>0.972</a:t>
                       </a:r>
                     </a:p>
@@ -8905,6 +8915,7 @@
                         </a:defRPr>
                       </a:pPr>
                       <a:r>
+                        <a:rPr dirty="0"/>
                         <a:t>0.899</a:t>
                       </a:r>
                     </a:p>
@@ -8929,6 +8940,7 @@
                         </a:defRPr>
                       </a:pPr>
                       <a:r>
+                        <a:rPr dirty="0"/>
                         <a:t>0.970</a:t>
                       </a:r>
                     </a:p>
@@ -8942,6 +8954,182 @@
                 <a:extLst>
                   <a:ext uri="{0D108BD9-81ED-4DB2-BD59-A6C34878D82A}">
                     <a16:rowId xmlns:a16="http://schemas.microsoft.com/office/drawing/2014/main" val="10006"/>
+                  </a:ext>
+                </a:extLst>
+              </a:tr>
+              <a:tr h="457200">
+                <a:tc>
+                  <a:txBody>
+                    <a:bodyPr/>
+                    <a:lstStyle/>
+                    <a:p>
+                      <a:pPr algn="l">
+                        <a:defRPr sz="1300" b="1">
+                          <a:solidFill>
+                            <a:srgbClr val="1F2937"/>
+                          </a:solidFill>
+                          <a:latin typeface="Calibri"/>
+                        </a:defRPr>
+                      </a:pPr>
+                      <a:r>
+                        <a:t>Total ticks</a:t>
+                      </a:r>
+                    </a:p>
+                  </a:txBody>
+                  <a:tcPr anchor="ctr">
+                    <a:solidFill>
+                      <a:srgbClr val="EEF3FB"/>
+                    </a:solidFill>
+                  </a:tcPr>
+                </a:tc>
+                <a:tc>
+                  <a:txBody>
+                    <a:bodyPr/>
+                    <a:lstStyle/>
+                    <a:p>
+                      <a:pPr algn="ctr">
+                        <a:defRPr sz="1300" b="1">
+                          <a:solidFill>
+                            <a:srgbClr val="1F2937"/>
+                          </a:solidFill>
+                          <a:latin typeface="Calibri"/>
+                        </a:defRPr>
+                      </a:pPr>
+                      <a:r>
+                        <a:t>500</a:t>
+                      </a:r>
+                    </a:p>
+                  </a:txBody>
+                  <a:tcPr anchor="ctr">
+                    <a:solidFill>
+                      <a:srgbClr val="EEF3FB"/>
+                    </a:solidFill>
+                  </a:tcPr>
+                </a:tc>
+                <a:tc>
+                  <a:txBody>
+                    <a:bodyPr/>
+                    <a:lstStyle/>
+                    <a:p>
+                      <a:pPr algn="ctr">
+                        <a:defRPr sz="1300" b="0">
+                          <a:solidFill>
+                            <a:srgbClr val="1F2937"/>
+                          </a:solidFill>
+                          <a:latin typeface="Calibri"/>
+                        </a:defRPr>
+                      </a:pPr>
+                      <a:r>
+                        <a:t>490</a:t>
+                      </a:r>
+                    </a:p>
+                  </a:txBody>
+                  <a:tcPr anchor="ctr">
+                    <a:solidFill>
+                      <a:srgbClr val="EEF3FB"/>
+                    </a:solidFill>
+                  </a:tcPr>
+                </a:tc>
+                <a:tc>
+                  <a:txBody>
+                    <a:bodyPr/>
+                    <a:lstStyle/>
+                    <a:p>
+                      <a:pPr algn="ctr">
+                        <a:defRPr sz="1300" b="0">
+                          <a:solidFill>
+                            <a:srgbClr val="1F2937"/>
+                          </a:solidFill>
+                          <a:latin typeface="Calibri"/>
+                        </a:defRPr>
+                      </a:pPr>
+                      <a:r>
+                        <a:t>401</a:t>
+                      </a:r>
+                    </a:p>
+                  </a:txBody>
+                  <a:tcPr anchor="ctr">
+                    <a:solidFill>
+                      <a:srgbClr val="EEF3FB"/>
+                    </a:solidFill>
+                  </a:tcPr>
+                </a:tc>
+                <a:tc>
+                  <a:txBody>
+                    <a:bodyPr/>
+                    <a:lstStyle/>
+                    <a:p>
+                      <a:pPr algn="ctr">
+                        <a:defRPr sz="1300" b="0">
+                          <a:solidFill>
+                            <a:srgbClr val="1F2937"/>
+                          </a:solidFill>
+                          <a:latin typeface="Calibri"/>
+                        </a:defRPr>
+                      </a:pPr>
+                      <a:r>
+                        <a:t>424</a:t>
+                      </a:r>
+                    </a:p>
+                  </a:txBody>
+                  <a:tcPr anchor="ctr">
+                    <a:solidFill>
+                      <a:srgbClr val="EEF3FB"/>
+                    </a:solidFill>
+                  </a:tcPr>
+                </a:tc>
+                <a:tc>
+                  <a:txBody>
+                    <a:bodyPr/>
+                    <a:lstStyle/>
+                    <a:p>
+                      <a:pPr algn="ctr">
+                        <a:defRPr sz="1300" b="0">
+                          <a:solidFill>
+                            <a:srgbClr val="1F2937"/>
+                          </a:solidFill>
+                          <a:latin typeface="Calibri"/>
+                        </a:defRPr>
+                      </a:pPr>
+                      <a:r>
+                        <a:t>338</a:t>
+                      </a:r>
+                    </a:p>
+                  </a:txBody>
+                  <a:tcPr anchor="ctr">
+                    <a:solidFill>
+                      <a:srgbClr val="D9F2E3"/>
+                    </a:solidFill>
+                  </a:tcPr>
+                </a:tc>
+                <a:tc>
+                  <a:txBody>
+                    <a:bodyPr/>
+                    <a:lstStyle/>
+                    <a:p>
+                      <a:pPr algn="ctr">
+                        <a:defRPr sz="1300" b="0">
+                          <a:solidFill>
+                            <a:srgbClr val="1F2937"/>
+                          </a:solidFill>
+                          <a:latin typeface="Calibri"/>
+                        </a:defRPr>
+                      </a:pPr>
+                      <a:r>
+                        <a:rPr dirty="0"/>
+                        <a:t>425</a:t>
+                      </a:r>
+                    </a:p>
+                  </a:txBody>
+                  <a:tcPr anchor="ctr">
+                    <a:solidFill>
+                      <a:srgbClr val="EEF3FB"/>
+                    </a:solidFill>
+                  </a:tcPr>
+                </a:tc>
+                <a:extLst>
+                  <a:ext uri="{0D108BD9-81ED-4DB2-BD59-A6C34878D82A}">
+                    <a16:rowId xmlns:a16="http://schemas.microsoft.com/office/drawing/2014/main" val="3944240344"/>
                   </a:ext>
                 </a:extLst>
               </a:tr>
@@ -10702,41 +10890,48 @@
                 <a:tableStyleId>{5C22544A-7EE6-4342-B048-85BDC9FD1C3A}</a:tableStyleId>
               </a:tblPr>
               <a:tblGrid>
-                <a:gridCol w="2011680">
+                <a:gridCol w="1828800">
                   <a:extLst>
                     <a:ext uri="{9D8B030D-6E8A-4147-A177-3AD203B41FA5}">
                       <a16:colId xmlns:a16="http://schemas.microsoft.com/office/drawing/2014/main" val="20000"/>
                     </a:ext>
                   </a:extLst>
                 </a:gridCol>
-                <a:gridCol w="2560320">
+                <a:gridCol w="2286000">
                   <a:extLst>
                     <a:ext uri="{9D8B030D-6E8A-4147-A177-3AD203B41FA5}">
                       <a16:colId xmlns:a16="http://schemas.microsoft.com/office/drawing/2014/main" val="20001"/>
                     </a:ext>
                   </a:extLst>
                 </a:gridCol>
-                <a:gridCol w="2286000">
+                <a:gridCol w="1920240">
                   <a:extLst>
                     <a:ext uri="{9D8B030D-6E8A-4147-A177-3AD203B41FA5}">
                       <a16:colId xmlns:a16="http://schemas.microsoft.com/office/drawing/2014/main" val="20002"/>
                     </a:ext>
                   </a:extLst>
                 </a:gridCol>
-                <a:gridCol w="2286000">
+                <a:gridCol w="1828800">
                   <a:extLst>
                     <a:ext uri="{9D8B030D-6E8A-4147-A177-3AD203B41FA5}">
                       <a16:colId xmlns:a16="http://schemas.microsoft.com/office/drawing/2014/main" val="20003"/>
                     </a:ext>
                   </a:extLst>
                 </a:gridCol>
-                <a:gridCol w="1828800">
+                <a:gridCol w="1371600">
                   <a:extLst>
                     <a:ext uri="{9D8B030D-6E8A-4147-A177-3AD203B41FA5}">
                       <a16:colId xmlns:a16="http://schemas.microsoft.com/office/drawing/2014/main" val="20004"/>
                     </a:ext>
                   </a:extLst>
                 </a:gridCol>
+                <a:gridCol w="1737360">
+                  <a:extLst>
+                    <a:ext uri="{9D8B030D-6E8A-4147-A177-3AD203B41FA5}">
+                      <a16:colId xmlns:a16="http://schemas.microsoft.com/office/drawing/2014/main" val="4024566597"/>
+                    </a:ext>
+                  </a:extLst>
+                </a:gridCol>
               </a:tblGrid>
               <a:tr h="400000">
                 <a:tc>
@@ -10835,6 +11030,27 @@
                           </a:solidFill>
                         </a:rPr>
                         <a:t>Most balanced</a:t>
+                      </a:r>
+                    </a:p>
+                  </a:txBody>
+                  <a:tcPr>
+                    <a:solidFill>
+                      <a:srgbClr val="1E2761"/>
+                    </a:solidFill>
+                  </a:tcPr>
+                </a:tc>
+                <a:tc>
+                  <a:txBody>
+                    <a:bodyPr/>
+                    <a:lstStyle/>
+                    <a:p>
+                      <a:r>
+                        <a:rPr sz="1300" b="1">
+                          <a:solidFill>
+                            <a:srgbClr val="FFFFFF"/>
+                          </a:solidFill>
+                        </a:rPr>
+                        <a:t>Fewest total ticks</a:t>
                       </a:r>
                     </a:p>
                   </a:txBody>
@@ -10936,6 +11152,23 @@
                   </a:txBody>
                   <a:tcPr/>
                 </a:tc>
+                <a:tc>
+                  <a:txBody>
+                    <a:bodyPr/>
+                    <a:lstStyle/>
+                    <a:p>
+                      <a:r>
+                        <a:rPr sz="1300">
+                          <a:solidFill>
+                            <a:srgbClr val="1F2937"/>
+                          </a:solidFill>
+                        </a:rPr>
+                        <a:t>Cost Based (51.5)</a:t>
+                      </a:r>
+                    </a:p>
+                  </a:txBody>
+                  <a:tcPr/>
+                </a:tc>
                 <a:extLst>
                   <a:ext uri="{0D108BD9-81ED-4DB2-BD59-A6C34878D82A}">
                     <a16:rowId xmlns:a16="http://schemas.microsoft.com/office/drawing/2014/main" val="10001"/>
@@ -11028,6 +11261,23 @@
                   </a:txBody>
                   <a:tcPr/>
                 </a:tc>
+                <a:tc>
+                  <a:txBody>
+                    <a:bodyPr/>
+                    <a:lstStyle/>
+                    <a:p>
+                      <a:r>
+                        <a:rPr sz="1300">
+                          <a:solidFill>
+                            <a:srgbClr val="1F2937"/>
+                          </a:solidFill>
+                        </a:rPr>
+                        <a:t>Cost Based (43.5)</a:t>
+                      </a:r>
+                    </a:p>
+                  </a:txBody>
+                  <a:tcPr/>
+                </a:tc>
                 <a:extLst>
                   <a:ext uri="{0D108BD9-81ED-4DB2-BD59-A6C34878D82A}">
                     <a16:rowId xmlns:a16="http://schemas.microsoft.com/office/drawing/2014/main" val="10002"/>
@@ -11120,6 +11370,23 @@
                   </a:txBody>
                   <a:tcPr/>
                 </a:tc>
+                <a:tc>
+                  <a:txBody>
+                    <a:bodyPr/>
+                    <a:lstStyle/>
+                    <a:p>
+                      <a:r>
+                        <a:rPr sz="1300">
+                          <a:solidFill>
+                            <a:srgbClr val="1F2937"/>
+                          </a:solidFill>
+                        </a:rPr>
+                        <a:t>Cost Based (37.6)</a:t>
+                      </a:r>
+                    </a:p>
+                  </a:txBody>
+                  <a:tcPr/>
+                </a:tc>
                 <a:extLst>
                   <a:ext uri="{0D108BD9-81ED-4DB2-BD59-A6C34878D82A}">
                     <a16:rowId xmlns:a16="http://schemas.microsoft.com/office/drawing/2014/main" val="10003"/>
@@ -11207,6 +11474,23 @@
                           </a:solidFill>
                         </a:rPr>
                         <a:t>Round Robin</a:t>
+                      </a:r>
+                    </a:p>
+                  </a:txBody>
+                  <a:tcPr/>
+                </a:tc>
+                <a:tc>
+                  <a:txBody>
+                    <a:bodyPr/>
+                    <a:lstStyle/>
+                    <a:p>
+                      <a:r>
+                        <a:rPr sz="1300">
+                          <a:solidFill>
+                            <a:srgbClr val="1F2937"/>
+                          </a:solidFill>
+                        </a:rPr>
+                        <a:t>Cost Based (177.8)</a:t>
                       </a:r>
                     </a:p>
                   </a:txBody>
@@ -12563,7 +12847,7 @@
                             <a:srgbClr val="1F2937"/>
                           </a:solidFill>
                         </a:rPr>
-                        <a:t>Simplicity</a:t>
+                        <a:t>Total ticks (run length)</a:t>
                       </a:r>
                     </a:p>
                   </a:txBody>
@@ -12580,7 +12864,7 @@
                             <a:srgbClr val="1F2937"/>
                           </a:solidFill>
                         </a:rPr>
-                        <a:t>Nearest Car Simple (the baseline)</a:t>
+                        <a:t>Cost Based in every scenario</a:t>
                       </a:r>
                     </a:p>
                   </a:txBody>
@@ -12597,7 +12881,7 @@
                             <a:srgbClr val="1F2937"/>
                           </a:solidFill>
                         </a:rPr>
-                        <a:t>Its waits and energy are the poorest of the non-trivial options</a:t>
+                        <a:t>Nearest Car Simple in rush hour and the large building; Round Robin in uniform and sparse traffic</a:t>
                       </a:r>
                     </a:p>
                   </a:txBody>
@@ -12606,6 +12890,64 @@
                 <a:extLst>
                   <a:ext uri="{0D108BD9-81ED-4DB2-BD59-A6C34878D82A}">
                     <a16:rowId xmlns:a16="http://schemas.microsoft.com/office/drawing/2014/main" val="173493888"/>
+                  </a:ext>
+                </a:extLst>
+              </a:tr>
+              <a:tr h="400000">
+                <a:tc>
+                  <a:txBody>
+                    <a:bodyPr/>
+                    <a:lstStyle/>
+                    <a:p>
+                      <a:r>
+                        <a:rPr sz="1400">
+                          <a:solidFill>
+                            <a:srgbClr val="1F2937"/>
+                          </a:solidFill>
+                        </a:rPr>
+                        <a:t>Simplicity</a:t>
+                      </a:r>
+                    </a:p>
+                  </a:txBody>
+                  <a:tcPr/>
+                </a:tc>
+                <a:tc>
+                  <a:txBody>
+                    <a:bodyPr/>
+                    <a:lstStyle/>
+                    <a:p>
+                      <a:r>
+                        <a:rPr sz="1400">
+                          <a:solidFill>
+                            <a:srgbClr val="1F2937"/>
+                          </a:solidFill>
+                        </a:rPr>
+                        <a:t>Nearest Car Simple (the baseline)</a:t>
+                      </a:r>
+                    </a:p>
+                  </a:txBody>
+                  <a:tcPr/>
+                </a:tc>
+                <a:tc>
+                  <a:txBody>
+                    <a:bodyPr/>
+                    <a:lstStyle/>
+                    <a:p>
+                      <a:r>
+                        <a:rPr sz="1400">
+                          <a:solidFill>
+                            <a:srgbClr val="1F2937"/>
+                          </a:solidFill>
+                        </a:rPr>
+                        <a:t>Its waits and energy are the poorest of the non-trivial options</a:t>
+                      </a:r>
+                    </a:p>
+                  </a:txBody>
+                  <a:tcPr/>
+                </a:tc>
+                <a:extLst>
+                  <a:ext uri="{0D108BD9-81ED-4DB2-BD59-A6C34878D82A}">
+                    <a16:rowId xmlns:a16="http://schemas.microsoft.com/office/drawing/2014/main" val="437973950"/>
                   </a:ext>
                 </a:extLst>
               </a:tr>
@@ -14522,6 +14864,181 @@
                   </a:ext>
                 </a:extLst>
               </a:tr>
+              <a:tr h="457200">
+                <a:tc>
+                  <a:txBody>
+                    <a:bodyPr/>
+                    <a:lstStyle/>
+                    <a:p>
+                      <a:pPr algn="l">
+                        <a:defRPr sz="1300" b="1">
+                          <a:solidFill>
+                            <a:srgbClr val="1F2937"/>
+                          </a:solidFill>
+                          <a:latin typeface="Calibri"/>
+                        </a:defRPr>
+                      </a:pPr>
+                      <a:r>
+                        <a:t>Total ticks</a:t>
+                      </a:r>
+                    </a:p>
+                  </a:txBody>
+                  <a:tcPr anchor="ctr">
+                    <a:solidFill>
+                      <a:srgbClr val="EEF3FB"/>
+                    </a:solidFill>
+                  </a:tcPr>
+                </a:tc>
+                <a:tc>
+                  <a:txBody>
+                    <a:bodyPr/>
+                    <a:lstStyle/>
+                    <a:p>
+                      <a:pPr algn="ctr">
+                        <a:defRPr sz="1300" b="1">
+                          <a:solidFill>
+                            <a:srgbClr val="1F2937"/>
+                          </a:solidFill>
+                          <a:latin typeface="Calibri"/>
+                        </a:defRPr>
+                      </a:pPr>
+                      <a:r>
+                        <a:t>53.2</a:t>
+                      </a:r>
+                    </a:p>
+                  </a:txBody>
+                  <a:tcPr anchor="ctr">
+                    <a:solidFill>
+                      <a:srgbClr val="EEF3FB"/>
+                    </a:solidFill>
+                  </a:tcPr>
+                </a:tc>
+                <a:tc>
+                  <a:txBody>
+                    <a:bodyPr/>
+                    <a:lstStyle/>
+                    <a:p>
+                      <a:pPr algn="ctr">
+                        <a:defRPr sz="1300" b="0">
+                          <a:solidFill>
+                            <a:srgbClr val="1F2937"/>
+                          </a:solidFill>
+                          <a:latin typeface="Calibri"/>
+                        </a:defRPr>
+                      </a:pPr>
+                      <a:r>
+                        <a:t>51.9</a:t>
+                      </a:r>
+                    </a:p>
+                  </a:txBody>
+                  <a:tcPr anchor="ctr">
+                    <a:solidFill>
+                      <a:srgbClr val="EEF3FB"/>
+                    </a:solidFill>
+                  </a:tcPr>
+                </a:tc>
+                <a:tc>
+                  <a:txBody>
+                    <a:bodyPr/>
+                    <a:lstStyle/>
+                    <a:p>
+                      <a:pPr algn="ctr">
+                        <a:defRPr sz="1300" b="0">
+                          <a:solidFill>
+                            <a:srgbClr val="1F2937"/>
+                          </a:solidFill>
+                          <a:latin typeface="Calibri"/>
+                        </a:defRPr>
+                      </a:pPr>
+                      <a:r>
+                        <a:t>47.8</a:t>
+                      </a:r>
+                    </a:p>
+                  </a:txBody>
+                  <a:tcPr anchor="ctr">
+                    <a:solidFill>
+                      <a:srgbClr val="D9F2E3"/>
+                    </a:solidFill>
+                  </a:tcPr>
+                </a:tc>
+                <a:tc>
+                  <a:txBody>
+                    <a:bodyPr/>
+                    <a:lstStyle/>
+                    <a:p>
+                      <a:pPr algn="ctr">
+                        <a:defRPr sz="1300" b="0">
+                          <a:solidFill>
+                            <a:srgbClr val="1F2937"/>
+                          </a:solidFill>
+                          <a:latin typeface="Calibri"/>
+                        </a:defRPr>
+                      </a:pPr>
+                      <a:r>
+                        <a:t>58.5</a:t>
+                      </a:r>
+                    </a:p>
+                  </a:txBody>
+                  <a:tcPr anchor="ctr">
+                    <a:solidFill>
+                      <a:srgbClr val="EEF3FB"/>
+                    </a:solidFill>
+                  </a:tcPr>
+                </a:tc>
+                <a:tc>
+                  <a:txBody>
+                    <a:bodyPr/>
+                    <a:lstStyle/>
+                    <a:p>
+                      <a:pPr algn="ctr">
+                        <a:defRPr sz="1300" b="0">
+                          <a:solidFill>
+                            <a:srgbClr val="1F2937"/>
+                          </a:solidFill>
+                          <a:latin typeface="Calibri"/>
+                        </a:defRPr>
+                      </a:pPr>
+                      <a:r>
+                        <a:t>48.2</a:t>
+                      </a:r>
+                    </a:p>
+                  </a:txBody>
+                  <a:tcPr anchor="ctr">
+                    <a:solidFill>
+                      <a:srgbClr val="EEF3FB"/>
+                    </a:solidFill>
+                  </a:tcPr>
+                </a:tc>
+                <a:tc>
+                  <a:txBody>
+                    <a:bodyPr/>
+                    <a:lstStyle/>
+                    <a:p>
+                      <a:pPr algn="ctr">
+                        <a:defRPr sz="1300" b="0">
+                          <a:solidFill>
+                            <a:srgbClr val="1F2937"/>
+                          </a:solidFill>
+                          <a:latin typeface="Calibri"/>
+                        </a:defRPr>
+                      </a:pPr>
+                      <a:r>
+                        <a:t>49.0</a:t>
+                      </a:r>
+                    </a:p>
+                  </a:txBody>
+                  <a:tcPr anchor="ctr">
+                    <a:solidFill>
+                      <a:srgbClr val="EEF3FB"/>
+                    </a:solidFill>
+                  </a:tcPr>
+                </a:tc>
+                <a:extLst>
+                  <a:ext uri="{0D108BD9-81ED-4DB2-BD59-A6C34878D82A}">
+                    <a16:rowId xmlns:a16="http://schemas.microsoft.com/office/drawing/2014/main" val="399370170"/>
+                  </a:ext>
+                </a:extLst>
+              </a:tr>
             </a:tbl>
           </a:graphicData>
         </a:graphic>
@@ -16132,6 +16649,181 @@
                   </a:ext>
                 </a:extLst>
               </a:tr>
+              <a:tr h="457200">
+                <a:tc>
+                  <a:txBody>
+                    <a:bodyPr/>
+                    <a:lstStyle/>
+                    <a:p>
+                      <a:pPr algn="l">
+                        <a:defRPr sz="1300" b="1">
+                          <a:solidFill>
+                            <a:srgbClr val="1F2937"/>
+                          </a:solidFill>
+                          <a:latin typeface="Calibri"/>
+                        </a:defRPr>
+                      </a:pPr>
+                      <a:r>
+                        <a:t>Total ticks</a:t>
+                      </a:r>
+                    </a:p>
+                  </a:txBody>
+                  <a:tcPr anchor="ctr">
+                    <a:solidFill>
+                      <a:srgbClr val="EEF3FB"/>
+                    </a:solidFill>
+                  </a:tcPr>
+                </a:tc>
+                <a:tc>
+                  <a:txBody>
+                    <a:bodyPr/>
+                    <a:lstStyle/>
+                    <a:p>
+                      <a:pPr algn="ctr">
+                        <a:defRPr sz="1300" b="1">
+                          <a:solidFill>
+                            <a:srgbClr val="1F2937"/>
+                          </a:solidFill>
+                          <a:latin typeface="Calibri"/>
+                        </a:defRPr>
+                      </a:pPr>
+                      <a:r>
+                        <a:t>74.2</a:t>
+                      </a:r>
+                    </a:p>
+                  </a:txBody>
+                  <a:tcPr anchor="ctr">
+                    <a:solidFill>
+                      <a:srgbClr val="EEF3FB"/>
+                    </a:solidFill>
+                  </a:tcPr>
+                </a:tc>
+                <a:tc>
+                  <a:txBody>
+                    <a:bodyPr/>
+                    <a:lstStyle/>
+                    <a:p>
+                      <a:pPr algn="ctr">
+                        <a:defRPr sz="1300" b="0">
+                          <a:solidFill>
+                            <a:srgbClr val="1F2937"/>
+                          </a:solidFill>
+                          <a:latin typeface="Calibri"/>
+                        </a:defRPr>
+                      </a:pPr>
+                      <a:r>
+                        <a:t>75.5</a:t>
+                      </a:r>
+                    </a:p>
+                  </a:txBody>
+                  <a:tcPr anchor="ctr">
+                    <a:solidFill>
+                      <a:srgbClr val="EEF3FB"/>
+                    </a:solidFill>
+                  </a:tcPr>
+                </a:tc>
+                <a:tc>
+                  <a:txBody>
+                    <a:bodyPr/>
+                    <a:lstStyle/>
+                    <a:p>
+                      <a:pPr algn="ctr">
+                        <a:defRPr sz="1300" b="0">
+                          <a:solidFill>
+                            <a:srgbClr val="1F2937"/>
+                          </a:solidFill>
+                          <a:latin typeface="Calibri"/>
+                        </a:defRPr>
+                      </a:pPr>
+                      <a:r>
+                        <a:t>67.7</a:t>
+                      </a:r>
+                    </a:p>
+                  </a:txBody>
+                  <a:tcPr anchor="ctr">
+                    <a:solidFill>
+                      <a:srgbClr val="EEF3FB"/>
+                    </a:solidFill>
+                  </a:tcPr>
+                </a:tc>
+                <a:tc>
+                  <a:txBody>
+                    <a:bodyPr/>
+                    <a:lstStyle/>
+                    <a:p>
+                      <a:pPr algn="ctr">
+                        <a:defRPr sz="1300" b="0">
+                          <a:solidFill>
+                            <a:srgbClr val="1F2937"/>
+                          </a:solidFill>
+                          <a:latin typeface="Calibri"/>
+                        </a:defRPr>
+                      </a:pPr>
+                      <a:r>
+                        <a:t>75.8</a:t>
+                      </a:r>
+                    </a:p>
+                  </a:txBody>
+                  <a:tcPr anchor="ctr">
+                    <a:solidFill>
+                      <a:srgbClr val="EEF3FB"/>
+                    </a:solidFill>
+                  </a:tcPr>
+                </a:tc>
+                <a:tc>
+                  <a:txBody>
+                    <a:bodyPr/>
+                    <a:lstStyle/>
+                    <a:p>
+                      <a:pPr algn="ctr">
+                        <a:defRPr sz="1300" b="0">
+                          <a:solidFill>
+                            <a:srgbClr val="1F2937"/>
+                          </a:solidFill>
+                          <a:latin typeface="Calibri"/>
+                        </a:defRPr>
+                      </a:pPr>
+                      <a:r>
+                        <a:t>54.8</a:t>
+                      </a:r>
+                    </a:p>
+                  </a:txBody>
+                  <a:tcPr anchor="ctr">
+                    <a:solidFill>
+                      <a:srgbClr val="D9F2E3"/>
+                    </a:solidFill>
+                  </a:tcPr>
+                </a:tc>
+                <a:tc>
+                  <a:txBody>
+                    <a:bodyPr/>
+                    <a:lstStyle/>
+                    <a:p>
+                      <a:pPr algn="ctr">
+                        <a:defRPr sz="1300" b="0">
+                          <a:solidFill>
+                            <a:srgbClr val="1F2937"/>
+                          </a:solidFill>
+                          <a:latin typeface="Calibri"/>
+                        </a:defRPr>
+                      </a:pPr>
+                      <a:r>
+                        <a:t>67.2</a:t>
+                      </a:r>
+                    </a:p>
+                  </a:txBody>
+                  <a:tcPr anchor="ctr">
+                    <a:solidFill>
+                      <a:srgbClr val="EEF3FB"/>
+                    </a:solidFill>
+                  </a:tcPr>
+                </a:tc>
+                <a:extLst>
+                  <a:ext uri="{0D108BD9-81ED-4DB2-BD59-A6C34878D82A}">
+                    <a16:rowId xmlns:a16="http://schemas.microsoft.com/office/drawing/2014/main" val="4215964379"/>
+                  </a:ext>
+                </a:extLst>
+              </a:tr>
             </a:tbl>
           </a:graphicData>
         </a:graphic>
@@ -17742,6 +18434,181 @@
                   </a:ext>
                 </a:extLst>
               </a:tr>
+              <a:tr h="457200">
+                <a:tc>
+                  <a:txBody>
+                    <a:bodyPr/>
+                    <a:lstStyle/>
+                    <a:p>
+                      <a:pPr algn="l">
+                        <a:defRPr sz="1300" b="1">
+                          <a:solidFill>
+                            <a:srgbClr val="1F2937"/>
+                          </a:solidFill>
+                          <a:latin typeface="Calibri"/>
+                        </a:defRPr>
+                      </a:pPr>
+                      <a:r>
+                        <a:t>Total ticks</a:t>
+                      </a:r>
+                    </a:p>
+                  </a:txBody>
+                  <a:tcPr anchor="ctr">
+                    <a:solidFill>
+                      <a:srgbClr val="EEF3FB"/>
+                    </a:solidFill>
+                  </a:tcPr>
+                </a:tc>
+                <a:tc>
+                  <a:txBody>
+                    <a:bodyPr/>
+                    <a:lstStyle/>
+                    <a:p>
+                      <a:pPr algn="ctr">
+                        <a:defRPr sz="1300" b="1">
+                          <a:solidFill>
+                            <a:srgbClr val="1F2937"/>
+                          </a:solidFill>
+                          <a:latin typeface="Calibri"/>
+                        </a:defRPr>
+                      </a:pPr>
+                      <a:r>
+                        <a:t>52.0</a:t>
+                      </a:r>
+                    </a:p>
+                  </a:txBody>
+                  <a:tcPr anchor="ctr">
+                    <a:solidFill>
+                      <a:srgbClr val="EEF3FB"/>
+                    </a:solidFill>
+                  </a:tcPr>
+                </a:tc>
+                <a:tc>
+                  <a:txBody>
+                    <a:bodyPr/>
+                    <a:lstStyle/>
+                    <a:p>
+                      <a:pPr algn="ctr">
+                        <a:defRPr sz="1300" b="0">
+                          <a:solidFill>
+                            <a:srgbClr val="1F2937"/>
+                          </a:solidFill>
+                          <a:latin typeface="Calibri"/>
+                        </a:defRPr>
+                      </a:pPr>
+                      <a:r>
+                        <a:t>50.1</a:t>
+                      </a:r>
+                    </a:p>
+                  </a:txBody>
+                  <a:tcPr anchor="ctr">
+                    <a:solidFill>
+                      <a:srgbClr val="EEF3FB"/>
+                    </a:solidFill>
+                  </a:tcPr>
+                </a:tc>
+                <a:tc>
+                  <a:txBody>
+                    <a:bodyPr/>
+                    <a:lstStyle/>
+                    <a:p>
+                      <a:pPr algn="ctr">
+                        <a:defRPr sz="1300" b="0">
+                          <a:solidFill>
+                            <a:srgbClr val="1F2937"/>
+                          </a:solidFill>
+                          <a:latin typeface="Calibri"/>
+                        </a:defRPr>
+                      </a:pPr>
+                      <a:r>
+                        <a:t>44.6</a:t>
+                      </a:r>
+                    </a:p>
+                  </a:txBody>
+                  <a:tcPr anchor="ctr">
+                    <a:solidFill>
+                      <a:srgbClr val="EEF3FB"/>
+                    </a:solidFill>
+                  </a:tcPr>
+                </a:tc>
+                <a:tc>
+                  <a:txBody>
+                    <a:bodyPr/>
+                    <a:lstStyle/>
+                    <a:p>
+                      <a:pPr algn="ctr">
+                        <a:defRPr sz="1300" b="0">
+                          <a:solidFill>
+                            <a:srgbClr val="1F2937"/>
+                          </a:solidFill>
+                          <a:latin typeface="Calibri"/>
+                        </a:defRPr>
+                      </a:pPr>
+                      <a:r>
+                        <a:t>48.9</a:t>
+                      </a:r>
+                    </a:p>
+                  </a:txBody>
+                  <a:tcPr anchor="ctr">
+                    <a:solidFill>
+                      <a:srgbClr val="EEF3FB"/>
+                    </a:solidFill>
+                  </a:tcPr>
+                </a:tc>
+                <a:tc>
+                  <a:txBody>
+                    <a:bodyPr/>
+                    <a:lstStyle/>
+                    <a:p>
+                      <a:pPr algn="ctr">
+                        <a:defRPr sz="1300" b="0">
+                          <a:solidFill>
+                            <a:srgbClr val="1F2937"/>
+                          </a:solidFill>
+                          <a:latin typeface="Calibri"/>
+                        </a:defRPr>
+                      </a:pPr>
+                      <a:r>
+                        <a:t>43.5</a:t>
+                      </a:r>
+                    </a:p>
+                  </a:txBody>
+                  <a:tcPr anchor="ctr">
+                    <a:solidFill>
+                      <a:srgbClr val="D9F2E3"/>
+                    </a:solidFill>
+                  </a:tcPr>
+                </a:tc>
+                <a:tc>
+                  <a:txBody>
+                    <a:bodyPr/>
+                    <a:lstStyle/>
+                    <a:p>
+                      <a:pPr algn="ctr">
+                        <a:defRPr sz="1300" b="0">
+                          <a:solidFill>
+                            <a:srgbClr val="1F2937"/>
+                          </a:solidFill>
+                          <a:latin typeface="Calibri"/>
+                        </a:defRPr>
+                      </a:pPr>
+                      <a:r>
+                        <a:t>47.1</a:t>
+                      </a:r>
+                    </a:p>
+                  </a:txBody>
+                  <a:tcPr anchor="ctr">
+                    <a:solidFill>
+                      <a:srgbClr val="EEF3FB"/>
+                    </a:solidFill>
+                  </a:tcPr>
+                </a:tc>
+                <a:extLst>
+                  <a:ext uri="{0D108BD9-81ED-4DB2-BD59-A6C34878D82A}">
+                    <a16:rowId xmlns:a16="http://schemas.microsoft.com/office/drawing/2014/main" val="1703393963"/>
+                  </a:ext>
+                </a:extLst>
+              </a:tr>
             </a:tbl>
           </a:graphicData>
         </a:graphic>
@@ -19352,6 +20219,181 @@
                   </a:ext>
                 </a:extLst>
               </a:tr>
+              <a:tr h="457200">
+                <a:tc>
+                  <a:txBody>
+                    <a:bodyPr/>
+                    <a:lstStyle/>
+                    <a:p>
+                      <a:pPr algn="l">
+                        <a:defRPr sz="1300" b="1">
+                          <a:solidFill>
+                            <a:srgbClr val="1F2937"/>
+                          </a:solidFill>
+                          <a:latin typeface="Calibri"/>
+                        </a:defRPr>
+                      </a:pPr>
+                      <a:r>
+                        <a:t>Total ticks</a:t>
+                      </a:r>
+                    </a:p>
+                  </a:txBody>
+                  <a:tcPr anchor="ctr">
+                    <a:solidFill>
+                      <a:srgbClr val="EEF3FB"/>
+                    </a:solidFill>
+                  </a:tcPr>
+                </a:tc>
+                <a:tc>
+                  <a:txBody>
+                    <a:bodyPr/>
+                    <a:lstStyle/>
+                    <a:p>
+                      <a:pPr algn="ctr">
+                        <a:defRPr sz="1300" b="1">
+                          <a:solidFill>
+                            <a:srgbClr val="1F2937"/>
+                          </a:solidFill>
+                          <a:latin typeface="Calibri"/>
+                        </a:defRPr>
+                      </a:pPr>
+                      <a:r>
+                        <a:t>40.7</a:t>
+                      </a:r>
+                    </a:p>
+                  </a:txBody>
+                  <a:tcPr anchor="ctr">
+                    <a:solidFill>
+                      <a:srgbClr val="EEF3FB"/>
+                    </a:solidFill>
+                  </a:tcPr>
+                </a:tc>
+                <a:tc>
+                  <a:txBody>
+                    <a:bodyPr/>
+                    <a:lstStyle/>
+                    <a:p>
+                      <a:pPr algn="ctr">
+                        <a:defRPr sz="1300" b="0">
+                          <a:solidFill>
+                            <a:srgbClr val="1F2937"/>
+                          </a:solidFill>
+                          <a:latin typeface="Calibri"/>
+                        </a:defRPr>
+                      </a:pPr>
+                      <a:r>
+                        <a:t>38.5</a:t>
+                      </a:r>
+                    </a:p>
+                  </a:txBody>
+                  <a:tcPr anchor="ctr">
+                    <a:solidFill>
+                      <a:srgbClr val="EEF3FB"/>
+                    </a:solidFill>
+                  </a:tcPr>
+                </a:tc>
+                <a:tc>
+                  <a:txBody>
+                    <a:bodyPr/>
+                    <a:lstStyle/>
+                    <a:p>
+                      <a:pPr algn="ctr">
+                        <a:defRPr sz="1300" b="0">
+                          <a:solidFill>
+                            <a:srgbClr val="1F2937"/>
+                          </a:solidFill>
+                          <a:latin typeface="Calibri"/>
+                        </a:defRPr>
+                      </a:pPr>
+                      <a:r>
+                        <a:t>38.0</a:t>
+                      </a:r>
+                    </a:p>
+                  </a:txBody>
+                  <a:tcPr anchor="ctr">
+                    <a:solidFill>
+                      <a:srgbClr val="EEF3FB"/>
+                    </a:solidFill>
+                  </a:tcPr>
+                </a:tc>
+                <a:tc>
+                  <a:txBody>
+                    <a:bodyPr/>
+                    <a:lstStyle/>
+                    <a:p>
+                      <a:pPr algn="ctr">
+                        <a:defRPr sz="1300" b="0">
+                          <a:solidFill>
+                            <a:srgbClr val="1F2937"/>
+                          </a:solidFill>
+                          <a:latin typeface="Calibri"/>
+                        </a:defRPr>
+                      </a:pPr>
+                      <a:r>
+                        <a:t>38.4</a:t>
+                      </a:r>
+                    </a:p>
+                  </a:txBody>
+                  <a:tcPr anchor="ctr">
+                    <a:solidFill>
+                      <a:srgbClr val="EEF3FB"/>
+                    </a:solidFill>
+                  </a:tcPr>
+                </a:tc>
+                <a:tc>
+                  <a:txBody>
+                    <a:bodyPr/>
+                    <a:lstStyle/>
+                    <a:p>
+                      <a:pPr algn="ctr">
+                        <a:defRPr sz="1300" b="0">
+                          <a:solidFill>
+                            <a:srgbClr val="1F2937"/>
+                          </a:solidFill>
+                          <a:latin typeface="Calibri"/>
+                        </a:defRPr>
+                      </a:pPr>
+                      <a:r>
+                        <a:t>37.6</a:t>
+                      </a:r>
+                    </a:p>
+                  </a:txBody>
+                  <a:tcPr anchor="ctr">
+                    <a:solidFill>
+                      <a:srgbClr val="D9F2E3"/>
+                    </a:solidFill>
+                  </a:tcPr>
+                </a:tc>
+                <a:tc>
+                  <a:txBody>
+                    <a:bodyPr/>
+                    <a:lstStyle/>
+                    <a:p>
+                      <a:pPr algn="ctr">
+                        <a:defRPr sz="1300" b="0">
+                          <a:solidFill>
+                            <a:srgbClr val="1F2937"/>
+                          </a:solidFill>
+                          <a:latin typeface="Calibri"/>
+                        </a:defRPr>
+                      </a:pPr>
+                      <a:r>
+                        <a:t>38.0</a:t>
+                      </a:r>
+                    </a:p>
+                  </a:txBody>
+                  <a:tcPr anchor="ctr">
+                    <a:solidFill>
+                      <a:srgbClr val="EEF3FB"/>
+                    </a:solidFill>
+                  </a:tcPr>
+                </a:tc>
+                <a:extLst>
+                  <a:ext uri="{0D108BD9-81ED-4DB2-BD59-A6C34878D82A}">
+                    <a16:rowId xmlns:a16="http://schemas.microsoft.com/office/drawing/2014/main" val="936949732"/>
+                  </a:ext>
+                </a:extLst>
+              </a:tr>
             </a:tbl>
           </a:graphicData>
         </a:graphic>
@@ -21523,6 +22565,181 @@
                 <a:extLst>
                   <a:ext uri="{0D108BD9-81ED-4DB2-BD59-A6C34878D82A}">
                     <a16:rowId xmlns:a16="http://schemas.microsoft.com/office/drawing/2014/main" val="10006"/>
+                  </a:ext>
+                </a:extLst>
+              </a:tr>
+              <a:tr h="457200">
+                <a:tc>
+                  <a:txBody>
+                    <a:bodyPr/>
+                    <a:lstStyle/>
+                    <a:p>
+                      <a:pPr algn="l">
+                        <a:defRPr sz="1300" b="1">
+                          <a:solidFill>
+                            <a:srgbClr val="1F2937"/>
+                          </a:solidFill>
+                          <a:latin typeface="Calibri"/>
+                        </a:defRPr>
+                      </a:pPr>
+                      <a:r>
+                        <a:t>Total ticks</a:t>
+                      </a:r>
+                    </a:p>
+                  </a:txBody>
+                  <a:tcPr anchor="ctr">
+                    <a:solidFill>
+                      <a:srgbClr val="EEF3FB"/>
+                    </a:solidFill>
+                  </a:tcPr>
+                </a:tc>
+                <a:tc>
+                  <a:txBody>
+                    <a:bodyPr/>
+                    <a:lstStyle/>
+                    <a:p>
+                      <a:pPr algn="ctr">
+                        <a:defRPr sz="1300" b="1">
+                          <a:solidFill>
+                            <a:srgbClr val="1F2937"/>
+                          </a:solidFill>
+                          <a:latin typeface="Calibri"/>
+                        </a:defRPr>
+                      </a:pPr>
+                      <a:r>
+                        <a:t>299.7</a:t>
+                      </a:r>
+                    </a:p>
+                  </a:txBody>
+                  <a:tcPr anchor="ctr">
+                    <a:solidFill>
+                      <a:srgbClr val="EEF3FB"/>
+                    </a:solidFill>
+                  </a:tcPr>
+                </a:tc>
+                <a:tc>
+                  <a:txBody>
+                    <a:bodyPr/>
+                    <a:lstStyle/>
+                    <a:p>
+                      <a:pPr algn="ctr">
+                        <a:defRPr sz="1300" b="0">
+                          <a:solidFill>
+                            <a:srgbClr val="1F2937"/>
+                          </a:solidFill>
+                          <a:latin typeface="Calibri"/>
+                        </a:defRPr>
+                      </a:pPr>
+                      <a:r>
+                        <a:t>246.2</a:t>
+                      </a:r>
+                    </a:p>
+                  </a:txBody>
+                  <a:tcPr anchor="ctr">
+                    <a:solidFill>
+                      <a:srgbClr val="EEF3FB"/>
+                    </a:solidFill>
+                  </a:tcPr>
+                </a:tc>
+                <a:tc>
+                  <a:txBody>
+                    <a:bodyPr/>
+                    <a:lstStyle/>
+                    <a:p>
+                      <a:pPr algn="ctr">
+                        <a:defRPr sz="1300" b="0">
+                          <a:solidFill>
+                            <a:srgbClr val="1F2937"/>
+                          </a:solidFill>
+                          <a:latin typeface="Calibri"/>
+                        </a:defRPr>
+                      </a:pPr>
+                      <a:r>
+                        <a:t>231.2</a:t>
+                      </a:r>
+                    </a:p>
+                  </a:txBody>
+                  <a:tcPr anchor="ctr">
+                    <a:solidFill>
+                      <a:srgbClr val="EEF3FB"/>
+                    </a:solidFill>
+                  </a:tcPr>
+                </a:tc>
+                <a:tc>
+                  <a:txBody>
+                    <a:bodyPr/>
+                    <a:lstStyle/>
+                    <a:p>
+                      <a:pPr algn="ctr">
+                        <a:defRPr sz="1300" b="0">
+                          <a:solidFill>
+                            <a:srgbClr val="1F2937"/>
+                          </a:solidFill>
+                          <a:latin typeface="Calibri"/>
+                        </a:defRPr>
+                      </a:pPr>
+                      <a:r>
+                        <a:t>315.5</a:t>
+                      </a:r>
+                    </a:p>
+                  </a:txBody>
+                  <a:tcPr anchor="ctr">
+                    <a:solidFill>
+                      <a:srgbClr val="EEF3FB"/>
+                    </a:solidFill>
+                  </a:tcPr>
+                </a:tc>
+                <a:tc>
+                  <a:txBody>
+                    <a:bodyPr/>
+                    <a:lstStyle/>
+                    <a:p>
+                      <a:pPr algn="ctr">
+                        <a:defRPr sz="1300" b="0">
+                          <a:solidFill>
+                            <a:srgbClr val="1F2937"/>
+                          </a:solidFill>
+                          <a:latin typeface="Calibri"/>
+                        </a:defRPr>
+                      </a:pPr>
+                      <a:r>
+                        <a:t>177.8</a:t>
+                      </a:r>
+                    </a:p>
+                  </a:txBody>
+                  <a:tcPr anchor="ctr">
+                    <a:solidFill>
+                      <a:srgbClr val="D9F2E3"/>
+                    </a:solidFill>
+                  </a:tcPr>
+                </a:tc>
+                <a:tc>
+                  <a:txBody>
+                    <a:bodyPr/>
+                    <a:lstStyle/>
+                    <a:p>
+                      <a:pPr algn="ctr">
+                        <a:defRPr sz="1300" b="0">
+                          <a:solidFill>
+                            <a:srgbClr val="1F2937"/>
+                          </a:solidFill>
+                          <a:latin typeface="Calibri"/>
+                        </a:defRPr>
+                      </a:pPr>
+                      <a:r>
+                        <a:t>233.4</a:t>
+                      </a:r>
+                    </a:p>
+                  </a:txBody>
+                  <a:tcPr anchor="ctr">
+                    <a:solidFill>
+                      <a:srgbClr val="EEF3FB"/>
+                    </a:solidFill>
+                  </a:tcPr>
+                </a:tc>
+                <a:extLst>
+                  <a:ext uri="{0D108BD9-81ED-4DB2-BD59-A6C34878D82A}">
+                    <a16:rowId xmlns:a16="http://schemas.microsoft.com/office/drawing/2014/main" val="3141766883"/>
                   </a:ext>
                 </a:extLst>
               </a:tr>

</xml_diff>

<commit_message>
Fixed some table lenghts for ppt
</commit_message>
<xml_diff>
--- a/docs/elevator_strategies_summary.pptx
+++ b/docs/elevator_strategies_summary.pptx
@@ -13401,11 +13401,17 @@
           <p:cNvGraphicFramePr>
             <a:graphicFrameLocks noGrp="1"/>
           </p:cNvGraphicFramePr>
-          <p:nvPr/>
+          <p:nvPr>
+            <p:extLst>
+              <p:ext uri="{D42A27DB-BD31-4B8C-83A1-F6EECF244321}">
+                <p14:modId xmlns:p14="http://schemas.microsoft.com/office/powerpoint/2010/main" val="2509122298"/>
+              </p:ext>
+            </p:extLst>
+          </p:nvPr>
         </p:nvGraphicFramePr>
         <p:xfrm>
           <a:off x="457200" y="1737360"/>
-          <a:ext cx="11795760" cy="3688080"/>
+          <a:ext cx="11421835" cy="4145280"/>
         </p:xfrm>
         <a:graphic>
           <a:graphicData uri="http://schemas.openxmlformats.org/drawingml/2006/table">
@@ -13414,49 +13420,49 @@
                 <a:tableStyleId>{5C22544A-7EE6-4342-B048-85BDC9FD1C3A}</a:tableStyleId>
               </a:tblPr>
               <a:tblGrid>
-                <a:gridCol w="2468880">
+                <a:gridCol w="2390617">
                   <a:extLst>
                     <a:ext uri="{9D8B030D-6E8A-4147-A177-3AD203B41FA5}">
                       <a16:colId xmlns:a16="http://schemas.microsoft.com/office/drawing/2014/main" val="20000"/>
                     </a:ext>
                   </a:extLst>
                 </a:gridCol>
-                <a:gridCol w="1554480">
+                <a:gridCol w="1505203">
                   <a:extLst>
                     <a:ext uri="{9D8B030D-6E8A-4147-A177-3AD203B41FA5}">
                       <a16:colId xmlns:a16="http://schemas.microsoft.com/office/drawing/2014/main" val="20001"/>
                     </a:ext>
                   </a:extLst>
                 </a:gridCol>
-                <a:gridCol w="1554480">
+                <a:gridCol w="1505203">
                   <a:extLst>
                     <a:ext uri="{9D8B030D-6E8A-4147-A177-3AD203B41FA5}">
                       <a16:colId xmlns:a16="http://schemas.microsoft.com/office/drawing/2014/main" val="20002"/>
                     </a:ext>
                   </a:extLst>
                 </a:gridCol>
-                <a:gridCol w="1554480">
+                <a:gridCol w="1505203">
                   <a:extLst>
                     <a:ext uri="{9D8B030D-6E8A-4147-A177-3AD203B41FA5}">
                       <a16:colId xmlns:a16="http://schemas.microsoft.com/office/drawing/2014/main" val="20003"/>
                     </a:ext>
                   </a:extLst>
                 </a:gridCol>
-                <a:gridCol w="1554480">
+                <a:gridCol w="1505203">
                   <a:extLst>
                     <a:ext uri="{9D8B030D-6E8A-4147-A177-3AD203B41FA5}">
                       <a16:colId xmlns:a16="http://schemas.microsoft.com/office/drawing/2014/main" val="20004"/>
                     </a:ext>
                   </a:extLst>
                 </a:gridCol>
-                <a:gridCol w="1554480">
+                <a:gridCol w="1505203">
                   <a:extLst>
                     <a:ext uri="{9D8B030D-6E8A-4147-A177-3AD203B41FA5}">
                       <a16:colId xmlns:a16="http://schemas.microsoft.com/office/drawing/2014/main" val="20005"/>
                     </a:ext>
                   </a:extLst>
                 </a:gridCol>
-                <a:gridCol w="1554480">
+                <a:gridCol w="1505203">
                   <a:extLst>
                     <a:ext uri="{9D8B030D-6E8A-4147-A177-3AD203B41FA5}">
                       <a16:colId xmlns:a16="http://schemas.microsoft.com/office/drawing/2014/main" val="20006"/>
@@ -14323,6 +14329,7 @@
                         </a:defRPr>
                       </a:pPr>
                       <a:r>
+                        <a:rPr dirty="0"/>
                         <a:t>17.6</a:t>
                       </a:r>
                     </a:p>
@@ -15023,6 +15030,7 @@
                         </a:defRPr>
                       </a:pPr>
                       <a:r>
+                        <a:rPr dirty="0"/>
                         <a:t>49.0</a:t>
                       </a:r>
                     </a:p>
@@ -15186,11 +15194,17 @@
           <p:cNvGraphicFramePr>
             <a:graphicFrameLocks noGrp="1"/>
           </p:cNvGraphicFramePr>
-          <p:nvPr/>
+          <p:nvPr>
+            <p:extLst>
+              <p:ext uri="{D42A27DB-BD31-4B8C-83A1-F6EECF244321}">
+                <p14:modId xmlns:p14="http://schemas.microsoft.com/office/powerpoint/2010/main" val="1142643273"/>
+              </p:ext>
+            </p:extLst>
+          </p:nvPr>
         </p:nvGraphicFramePr>
         <p:xfrm>
-          <a:off x="457200" y="1737360"/>
-          <a:ext cx="11795760" cy="3688080"/>
+          <a:off x="302079" y="1737360"/>
+          <a:ext cx="11266714" cy="4145280"/>
         </p:xfrm>
         <a:graphic>
           <a:graphicData uri="http://schemas.openxmlformats.org/drawingml/2006/table">
@@ -15199,49 +15213,49 @@
                 <a:tableStyleId>{5C22544A-7EE6-4342-B048-85BDC9FD1C3A}</a:tableStyleId>
               </a:tblPr>
               <a:tblGrid>
-                <a:gridCol w="2468880">
+                <a:gridCol w="2294164">
                   <a:extLst>
                     <a:ext uri="{9D8B030D-6E8A-4147-A177-3AD203B41FA5}">
                       <a16:colId xmlns:a16="http://schemas.microsoft.com/office/drawing/2014/main" val="20000"/>
                     </a:ext>
                   </a:extLst>
                 </a:gridCol>
-                <a:gridCol w="1554480">
+                <a:gridCol w="1477736">
                   <a:extLst>
                     <a:ext uri="{9D8B030D-6E8A-4147-A177-3AD203B41FA5}">
                       <a16:colId xmlns:a16="http://schemas.microsoft.com/office/drawing/2014/main" val="20001"/>
                     </a:ext>
                   </a:extLst>
                 </a:gridCol>
-                <a:gridCol w="1554480">
+                <a:gridCol w="1551214">
                   <a:extLst>
                     <a:ext uri="{9D8B030D-6E8A-4147-A177-3AD203B41FA5}">
                       <a16:colId xmlns:a16="http://schemas.microsoft.com/office/drawing/2014/main" val="20002"/>
                     </a:ext>
                   </a:extLst>
                 </a:gridCol>
-                <a:gridCol w="1554480">
+                <a:gridCol w="1551215">
                   <a:extLst>
                     <a:ext uri="{9D8B030D-6E8A-4147-A177-3AD203B41FA5}">
                       <a16:colId xmlns:a16="http://schemas.microsoft.com/office/drawing/2014/main" val="20003"/>
                     </a:ext>
                   </a:extLst>
                 </a:gridCol>
-                <a:gridCol w="1554480">
+                <a:gridCol w="1502228">
                   <a:extLst>
                     <a:ext uri="{9D8B030D-6E8A-4147-A177-3AD203B41FA5}">
                       <a16:colId xmlns:a16="http://schemas.microsoft.com/office/drawing/2014/main" val="20004"/>
                     </a:ext>
                   </a:extLst>
                 </a:gridCol>
-                <a:gridCol w="1554480">
+                <a:gridCol w="1257300">
                   <a:extLst>
                     <a:ext uri="{9D8B030D-6E8A-4147-A177-3AD203B41FA5}">
                       <a16:colId xmlns:a16="http://schemas.microsoft.com/office/drawing/2014/main" val="20005"/>
                     </a:ext>
                   </a:extLst>
                 </a:gridCol>
-                <a:gridCol w="1554480">
+                <a:gridCol w="1632857">
                   <a:extLst>
                     <a:ext uri="{9D8B030D-6E8A-4147-A177-3AD203B41FA5}">
                       <a16:colId xmlns:a16="http://schemas.microsoft.com/office/drawing/2014/main" val="20006"/>
@@ -16808,6 +16822,7 @@
                         </a:defRPr>
                       </a:pPr>
                       <a:r>
+                        <a:rPr dirty="0"/>
                         <a:t>67.2</a:t>
                       </a:r>
                     </a:p>
@@ -16971,11 +16986,17 @@
           <p:cNvGraphicFramePr>
             <a:graphicFrameLocks noGrp="1"/>
           </p:cNvGraphicFramePr>
-          <p:nvPr/>
+          <p:nvPr>
+            <p:extLst>
+              <p:ext uri="{D42A27DB-BD31-4B8C-83A1-F6EECF244321}">
+                <p14:modId xmlns:p14="http://schemas.microsoft.com/office/powerpoint/2010/main" val="3702821163"/>
+              </p:ext>
+            </p:extLst>
+          </p:nvPr>
         </p:nvGraphicFramePr>
         <p:xfrm>
-          <a:off x="457200" y="1737360"/>
-          <a:ext cx="11795760" cy="3688080"/>
+          <a:off x="457201" y="1737360"/>
+          <a:ext cx="11323863" cy="4145280"/>
         </p:xfrm>
         <a:graphic>
           <a:graphicData uri="http://schemas.openxmlformats.org/drawingml/2006/table">
@@ -16984,49 +17005,49 @@
                 <a:tableStyleId>{5C22544A-7EE6-4342-B048-85BDC9FD1C3A}</a:tableStyleId>
               </a:tblPr>
               <a:tblGrid>
-                <a:gridCol w="2468880">
+                <a:gridCol w="2370111">
                   <a:extLst>
                     <a:ext uri="{9D8B030D-6E8A-4147-A177-3AD203B41FA5}">
                       <a16:colId xmlns:a16="http://schemas.microsoft.com/office/drawing/2014/main" val="20000"/>
                     </a:ext>
                   </a:extLst>
                 </a:gridCol>
-                <a:gridCol w="1554480">
+                <a:gridCol w="1492292">
                   <a:extLst>
                     <a:ext uri="{9D8B030D-6E8A-4147-A177-3AD203B41FA5}">
                       <a16:colId xmlns:a16="http://schemas.microsoft.com/office/drawing/2014/main" val="20001"/>
                     </a:ext>
                   </a:extLst>
                 </a:gridCol>
-                <a:gridCol w="1554480">
+                <a:gridCol w="1492292">
                   <a:extLst>
                     <a:ext uri="{9D8B030D-6E8A-4147-A177-3AD203B41FA5}">
                       <a16:colId xmlns:a16="http://schemas.microsoft.com/office/drawing/2014/main" val="20002"/>
                     </a:ext>
                   </a:extLst>
                 </a:gridCol>
-                <a:gridCol w="1554480">
+                <a:gridCol w="1492292">
                   <a:extLst>
                     <a:ext uri="{9D8B030D-6E8A-4147-A177-3AD203B41FA5}">
                       <a16:colId xmlns:a16="http://schemas.microsoft.com/office/drawing/2014/main" val="20003"/>
                     </a:ext>
                   </a:extLst>
                 </a:gridCol>
-                <a:gridCol w="1554480">
+                <a:gridCol w="1492292">
                   <a:extLst>
                     <a:ext uri="{9D8B030D-6E8A-4147-A177-3AD203B41FA5}">
                       <a16:colId xmlns:a16="http://schemas.microsoft.com/office/drawing/2014/main" val="20004"/>
                     </a:ext>
                   </a:extLst>
                 </a:gridCol>
-                <a:gridCol w="1554480">
+                <a:gridCol w="1492292">
                   <a:extLst>
                     <a:ext uri="{9D8B030D-6E8A-4147-A177-3AD203B41FA5}">
                       <a16:colId xmlns:a16="http://schemas.microsoft.com/office/drawing/2014/main" val="20005"/>
                     </a:ext>
                   </a:extLst>
                 </a:gridCol>
-                <a:gridCol w="1554480">
+                <a:gridCol w="1492292">
                   <a:extLst>
                     <a:ext uri="{9D8B030D-6E8A-4147-A177-3AD203B41FA5}">
                       <a16:colId xmlns:a16="http://schemas.microsoft.com/office/drawing/2014/main" val="20006"/>
@@ -17543,6 +17564,7 @@
                         </a:defRPr>
                       </a:pPr>
                       <a:r>
+                        <a:rPr dirty="0"/>
                         <a:t>21.3</a:t>
                       </a:r>
                     </a:p>
@@ -18593,6 +18615,7 @@
                         </a:defRPr>
                       </a:pPr>
                       <a:r>
+                        <a:rPr dirty="0"/>
                         <a:t>47.1</a:t>
                       </a:r>
                     </a:p>
@@ -18756,11 +18779,17 @@
           <p:cNvGraphicFramePr>
             <a:graphicFrameLocks noGrp="1"/>
           </p:cNvGraphicFramePr>
-          <p:nvPr/>
+          <p:nvPr>
+            <p:extLst>
+              <p:ext uri="{D42A27DB-BD31-4B8C-83A1-F6EECF244321}">
+                <p14:modId xmlns:p14="http://schemas.microsoft.com/office/powerpoint/2010/main" val="279443411"/>
+              </p:ext>
+            </p:extLst>
+          </p:nvPr>
         </p:nvGraphicFramePr>
         <p:xfrm>
           <a:off x="457200" y="1737360"/>
-          <a:ext cx="11795760" cy="3688080"/>
+          <a:ext cx="11438164" cy="4145280"/>
         </p:xfrm>
         <a:graphic>
           <a:graphicData uri="http://schemas.openxmlformats.org/drawingml/2006/table">
@@ -18769,49 +18798,49 @@
                 <a:tableStyleId>{5C22544A-7EE6-4342-B048-85BDC9FD1C3A}</a:tableStyleId>
               </a:tblPr>
               <a:tblGrid>
-                <a:gridCol w="2468880">
+                <a:gridCol w="2394034">
                   <a:extLst>
                     <a:ext uri="{9D8B030D-6E8A-4147-A177-3AD203B41FA5}">
                       <a16:colId xmlns:a16="http://schemas.microsoft.com/office/drawing/2014/main" val="20000"/>
                     </a:ext>
                   </a:extLst>
                 </a:gridCol>
-                <a:gridCol w="1554480">
+                <a:gridCol w="1507355">
                   <a:extLst>
                     <a:ext uri="{9D8B030D-6E8A-4147-A177-3AD203B41FA5}">
                       <a16:colId xmlns:a16="http://schemas.microsoft.com/office/drawing/2014/main" val="20001"/>
                     </a:ext>
                   </a:extLst>
                 </a:gridCol>
-                <a:gridCol w="1554480">
+                <a:gridCol w="1507355">
                   <a:extLst>
                     <a:ext uri="{9D8B030D-6E8A-4147-A177-3AD203B41FA5}">
                       <a16:colId xmlns:a16="http://schemas.microsoft.com/office/drawing/2014/main" val="20002"/>
                     </a:ext>
                   </a:extLst>
                 </a:gridCol>
-                <a:gridCol w="1554480">
+                <a:gridCol w="1507355">
                   <a:extLst>
                     <a:ext uri="{9D8B030D-6E8A-4147-A177-3AD203B41FA5}">
                       <a16:colId xmlns:a16="http://schemas.microsoft.com/office/drawing/2014/main" val="20003"/>
                     </a:ext>
                   </a:extLst>
                 </a:gridCol>
-                <a:gridCol w="1554480">
+                <a:gridCol w="1507355">
                   <a:extLst>
                     <a:ext uri="{9D8B030D-6E8A-4147-A177-3AD203B41FA5}">
                       <a16:colId xmlns:a16="http://schemas.microsoft.com/office/drawing/2014/main" val="20004"/>
                     </a:ext>
                   </a:extLst>
                 </a:gridCol>
-                <a:gridCol w="1554480">
+                <a:gridCol w="1507355">
                   <a:extLst>
                     <a:ext uri="{9D8B030D-6E8A-4147-A177-3AD203B41FA5}">
                       <a16:colId xmlns:a16="http://schemas.microsoft.com/office/drawing/2014/main" val="20005"/>
                     </a:ext>
                   </a:extLst>
                 </a:gridCol>
-                <a:gridCol w="1554480">
+                <a:gridCol w="1507355">
                   <a:extLst>
                     <a:ext uri="{9D8B030D-6E8A-4147-A177-3AD203B41FA5}">
                       <a16:colId xmlns:a16="http://schemas.microsoft.com/office/drawing/2014/main" val="20006"/>
@@ -18858,6 +18887,7 @@
                         </a:defRPr>
                       </a:pPr>
                       <a:r>
+                        <a:rPr dirty="0"/>
                         <a:t>ROUND_ROBIN</a:t>
                       </a:r>
                     </a:p>
@@ -20378,6 +20408,7 @@
                         </a:defRPr>
                       </a:pPr>
                       <a:r>
+                        <a:rPr dirty="0"/>
                         <a:t>38.0</a:t>
                       </a:r>
                     </a:p>
@@ -21105,11 +21136,17 @@
           <p:cNvGraphicFramePr>
             <a:graphicFrameLocks noGrp="1"/>
           </p:cNvGraphicFramePr>
-          <p:nvPr/>
+          <p:nvPr>
+            <p:extLst>
+              <p:ext uri="{D42A27DB-BD31-4B8C-83A1-F6EECF244321}">
+                <p14:modId xmlns:p14="http://schemas.microsoft.com/office/powerpoint/2010/main" val="3530306409"/>
+              </p:ext>
+            </p:extLst>
+          </p:nvPr>
         </p:nvGraphicFramePr>
         <p:xfrm>
           <a:off x="457200" y="1737360"/>
-          <a:ext cx="11795760" cy="3688080"/>
+          <a:ext cx="11462659" cy="4145280"/>
         </p:xfrm>
         <a:graphic>
           <a:graphicData uri="http://schemas.openxmlformats.org/drawingml/2006/table">
@@ -21118,49 +21155,49 @@
                 <a:tableStyleId>{5C22544A-7EE6-4342-B048-85BDC9FD1C3A}</a:tableStyleId>
               </a:tblPr>
               <a:tblGrid>
-                <a:gridCol w="2468880">
+                <a:gridCol w="2399161">
                   <a:extLst>
                     <a:ext uri="{9D8B030D-6E8A-4147-A177-3AD203B41FA5}">
                       <a16:colId xmlns:a16="http://schemas.microsoft.com/office/drawing/2014/main" val="20000"/>
                     </a:ext>
                   </a:extLst>
                 </a:gridCol>
-                <a:gridCol w="1554480">
+                <a:gridCol w="1510583">
                   <a:extLst>
                     <a:ext uri="{9D8B030D-6E8A-4147-A177-3AD203B41FA5}">
                       <a16:colId xmlns:a16="http://schemas.microsoft.com/office/drawing/2014/main" val="20001"/>
                     </a:ext>
                   </a:extLst>
                 </a:gridCol>
-                <a:gridCol w="1554480">
+                <a:gridCol w="1510583">
                   <a:extLst>
                     <a:ext uri="{9D8B030D-6E8A-4147-A177-3AD203B41FA5}">
                       <a16:colId xmlns:a16="http://schemas.microsoft.com/office/drawing/2014/main" val="20002"/>
                     </a:ext>
                   </a:extLst>
                 </a:gridCol>
-                <a:gridCol w="1554480">
+                <a:gridCol w="1510583">
                   <a:extLst>
                     <a:ext uri="{9D8B030D-6E8A-4147-A177-3AD203B41FA5}">
                       <a16:colId xmlns:a16="http://schemas.microsoft.com/office/drawing/2014/main" val="20003"/>
                     </a:ext>
                   </a:extLst>
                 </a:gridCol>
-                <a:gridCol w="1554480">
+                <a:gridCol w="1510583">
                   <a:extLst>
                     <a:ext uri="{9D8B030D-6E8A-4147-A177-3AD203B41FA5}">
                       <a16:colId xmlns:a16="http://schemas.microsoft.com/office/drawing/2014/main" val="20004"/>
                     </a:ext>
                   </a:extLst>
                 </a:gridCol>
-                <a:gridCol w="1554480">
+                <a:gridCol w="1510583">
                   <a:extLst>
                     <a:ext uri="{9D8B030D-6E8A-4147-A177-3AD203B41FA5}">
                       <a16:colId xmlns:a16="http://schemas.microsoft.com/office/drawing/2014/main" val="20005"/>
                     </a:ext>
                   </a:extLst>
                 </a:gridCol>
-                <a:gridCol w="1554480">
+                <a:gridCol w="1510583">
                   <a:extLst>
                     <a:ext uri="{9D8B030D-6E8A-4147-A177-3AD203B41FA5}">
                       <a16:colId xmlns:a16="http://schemas.microsoft.com/office/drawing/2014/main" val="20006"/>
@@ -22202,6 +22239,7 @@
                         </a:defRPr>
                       </a:pPr>
                       <a:r>
+                        <a:rPr dirty="0"/>
                         <a:t>42.08</a:t>
                       </a:r>
                     </a:p>
@@ -22727,6 +22765,7 @@
                         </a:defRPr>
                       </a:pPr>
                       <a:r>
+                        <a:rPr dirty="0"/>
                         <a:t>233.4</a:t>
                       </a:r>
                     </a:p>

</xml_diff>